<commit_message>
perf: add week 3
</commit_message>
<xml_diff>
--- a/2. Verzioniranje, strategije, kolaboracija u git-u, Ollama/blok-a-predavanje.pptx
+++ b/2. Verzioniranje, strategije, kolaboracija u git-u, Ollama/blok-a-predavanje.pptx
@@ -5265,7 +5265,7 @@
                 <a:ea typeface="Courier New" pitchFamily="34" charset="-122"/>
                 <a:cs typeface="Courier New" pitchFamily="34" charset="-120"/>
               </a:rPr>
-              <a:t>git switch main</a:t>
+              <a:t>git checkout main</a:t>
             </a:r>
             <a:endParaRPr lang="en-US" sz="1100" dirty="0"/>
           </a:p>
@@ -6899,7 +6899,7 @@
                 <a:ea typeface="Courier New" pitchFamily="34" charset="-122"/>
                 <a:cs typeface="Courier New" pitchFamily="34" charset="-120"/>
               </a:rPr>
-              <a:t>git switch main</a:t>
+              <a:t>git checkout main</a:t>
             </a:r>
             <a:endParaRPr lang="en-US" sz="1100" dirty="0"/>
           </a:p>
@@ -8634,7 +8634,7 @@
                 <a:ea typeface="Courier New" pitchFamily="34" charset="-122"/>
                 <a:cs typeface="Courier New" pitchFamily="34" charset="-120"/>
               </a:rPr>
-              <a:t>git switch feature</a:t>
+              <a:t>git checkout feature</a:t>
             </a:r>
             <a:endParaRPr lang="en-US" sz="1100" dirty="0"/>
           </a:p>
@@ -8668,7 +8668,7 @@
                 <a:ea typeface="Courier New" pitchFamily="34" charset="-122"/>
                 <a:cs typeface="Courier New" pitchFamily="34" charset="-120"/>
               </a:rPr>
-              <a:t>git switch main</a:t>
+              <a:t>git checkout main</a:t>
             </a:r>
             <a:endParaRPr lang="en-US" sz="1100" dirty="0"/>
           </a:p>
@@ -22769,7 +22769,7 @@
                 <a:ea typeface="Courier New" pitchFamily="34" charset="-122"/>
                 <a:cs typeface="Courier New" pitchFamily="34" charset="-120"/>
               </a:rPr>
-              <a:t>git switch -c</a:t>
+              <a:t>git checkout -b</a:t>
             </a:r>
             <a:endParaRPr lang="en-US" sz="800" dirty="0"/>
           </a:p>
@@ -25108,7 +25108,7 @@
                 <a:ea typeface="Courier New" pitchFamily="34" charset="-122"/>
                 <a:cs typeface="Courier New" pitchFamily="34" charset="-120"/>
               </a:rPr>
-              <a:t>git switch main</a:t>
+              <a:t>git checkout main</a:t>
             </a:r>
             <a:endParaRPr lang="en-US" sz="1100" dirty="0"/>
           </a:p>
@@ -30434,7 +30434,7 @@
                   <a:schemeClr val="tx1"/>
                 </a:solidFill>
               </a:rPr>
-              <a:t>Gdje smo sada: grana na kojoj radimo. git switch premješta HEAD.</a:t>
+              <a:t>Gdje smo sada: grana na kojoj radimo. git checkout premješta HEAD.</a:t>
             </a:r>
             <a:endParaRPr lang="en-US" sz="1200" dirty="0"/>
           </a:p>
@@ -31862,7 +31862,7 @@
                 <a:ea typeface="Courier New" pitchFamily="34" charset="-122"/>
                 <a:cs typeface="Courier New" pitchFamily="34" charset="-120"/>
               </a:rPr>
-              <a:t>git switch main</a:t>
+              <a:t>git checkout main</a:t>
             </a:r>
             <a:endParaRPr lang="en-US" sz="1100" dirty="0"/>
           </a:p>

</xml_diff>